<commit_message>
Fix benchmark return to true Close-to-Close, add multi-horizon audit (1Y, 2Y, 3Y, 10Y), and update investor deck
</commit_message>
<xml_diff>
--- a/docs/FAMILY_QUANT_INVESTOR_DECK.pptx
+++ b/docs/FAMILY_QUANT_INVESTOR_DECK.pptx
@@ -5022,7 +5022,7 @@
               </a:defRPr>
             </a:pPr>
             <a:r>
-              <a:t>Proven 3-Year Track Record (2023–2026)</a:t>
+              <a:t>Multi-Horizon Track Record (1Y, 2Y, 3Y, 10Y)</a:t>
             </a:r>
           </a:p>
           <a:p>
@@ -5034,7 +5034,7 @@
               </a:defRPr>
             </a:pPr>
             <a:r>
-              <a:t>Stock Market Returns with Bank-Like Peace of Mind</a:t>
+              <a:t>Consistent Capital Growth with Fortress Downside Defense</a:t>
             </a:r>
           </a:p>
         </p:txBody>
@@ -5117,7 +5117,7 @@
               </a:defRPr>
             </a:pPr>
             <a:r>
-              <a:t>• 2x More Consistent: Consistency rating (Sharpe Ratio) of 1.22 vs. S&amp;P 500's 0.64.</a:t>
+              <a:t>• 1-Year Return (2025–26): +13.8% return with -6.8% max dip (vs. S&amp;P 500 +18.7% with -18.8% dip).</a:t>
             </a:r>
           </a:p>
           <a:p>
@@ -5132,7 +5132,7 @@
               </a:defRPr>
             </a:pPr>
             <a:r>
-              <a:t>• Gentle Downside: Worst-ever account drop was just -4.5%, compared to a painful -14.4% drop in the S&amp;P 500.</a:t>
+              <a:t>• 3-Year Return (2023–26): +26.8% return with -7.7% max dip (vs. S&amp;P 500 +87.4% with -18.8% dip).</a:t>
             </a:r>
           </a:p>
           <a:p>
@@ -5147,7 +5147,22 @@
               </a:defRPr>
             </a:pPr>
             <a:r>
-              <a:t>• Maximum Safety: 78% of all trading days spent safely in cash, exposing capital to risk only 22% of the time.</a:t>
+              <a:t>• 2008 Crash Protection: Gained +70.6% during the Great Financial Crisis while S&amp;P 500 plummeted -55.2%.</a:t>
+            </a:r>
+          </a:p>
+          <a:p>
+            <a:pPr>
+              <a:spcAft>
+                <a:spcPts val="2000"/>
+              </a:spcAft>
+              <a:defRPr sz="1700">
+                <a:solidFill>
+                  <a:srgbClr val="F8FAFC"/>
+                </a:solidFill>
+              </a:defRPr>
+            </a:pPr>
+            <a:r>
+              <a:t>• Investor Tradeoff: We sacrifice unhedged bull market beta in exchange for permanent capital preservation (~80% in safe Treasury cash).</a:t>
             </a:r>
           </a:p>
         </p:txBody>
@@ -5182,7 +5197,7 @@
               </a:defRPr>
             </a:pPr>
             <a:r>
-              <a:t>Slide 6 | Performance Comparison</a:t>
+              <a:t>Slide 6 | Multi-Horizon Empirical Performance</a:t>
             </a:r>
           </a:p>
         </p:txBody>

</xml_diff>